<commit_message>
Update session schedule in README.md and add new materials for discussions on models and tools
- Adjusted the timing for the session on "Artificial Intelligence and data" to the afternoon slot.
- Added new PowerPoint presentations for practical implementation, optimization, and generative AI sessions.
- Introduced new files for discussions on models and tools to enhance course content.
</commit_message>
<xml_diff>
--- a/04. Inteligência Artificial e os Dados_Eder/Dados a base de toda IA no melhoramento_FIT796.pptx
+++ b/04. Inteligência Artificial e os Dados_Eder/Dados a base de toda IA no melhoramento_FIT796.pptx
@@ -182,9 +182,441 @@
 <file path=ppt/revisionInfo.xml><?xml version="1.0" encoding="utf-8"?>
 <p1510:revInfo xmlns:a="http://schemas.openxmlformats.org/drawingml/2006/main" xmlns:r="http://schemas.openxmlformats.org/officeDocument/2006/relationships" xmlns:p1510="http://schemas.microsoft.com/office/powerpoint/2015/10/main">
   <p1510:revLst>
-    <p1510:client id="{E45A2DEC-2261-48AF-B4A8-7B10B1CC645D}" v="1" dt="2026-10-27T15:45:50.880"/>
+    <p1510:client id="{65249966-4C54-4FD3-9316-4758CB4B92BF}" v="136" dt="2026-10-30T20:22:00.247"/>
   </p1510:revLst>
 </p1510:revInfo>
+</file>
+
+<file path=ppt/changesInfos/changesInfo1.xml><?xml version="1.0" encoding="utf-8"?>
+<pc:chgInfo xmlns:a="http://schemas.openxmlformats.org/drawingml/2006/main" xmlns:r="http://schemas.openxmlformats.org/officeDocument/2006/relationships" xmlns:ac="http://schemas.microsoft.com/office/drawing/2013/main/command" xmlns:pc="http://schemas.microsoft.com/office/powerpoint/2013/main/command">
+  <pc:docChgLst>
+    <pc:chgData name="Eder Silva" userId="9b7f41b4-798d-40cf-8f87-8e33ae7a0417" providerId="ADAL" clId="{DFF9E84E-5922-4F26-9EAD-8AB4E668133E}"/>
+    <pc:docChg chg="modSld">
+      <pc:chgData name="Eder Silva" userId="9b7f41b4-798d-40cf-8f87-8e33ae7a0417" providerId="ADAL" clId="{DFF9E84E-5922-4F26-9EAD-8AB4E668133E}" dt="2026-10-30T20:22:34.888" v="213" actId="1076"/>
+      <pc:docMkLst>
+        <pc:docMk/>
+      </pc:docMkLst>
+      <pc:sldChg chg="modSp mod">
+        <pc:chgData name="Eder Silva" userId="9b7f41b4-798d-40cf-8f87-8e33ae7a0417" providerId="ADAL" clId="{DFF9E84E-5922-4F26-9EAD-8AB4E668133E}" dt="2026-10-30T20:19:52.601" v="1" actId="1076"/>
+        <pc:sldMkLst>
+          <pc:docMk/>
+          <pc:sldMk cId="2133836751" sldId="333"/>
+        </pc:sldMkLst>
+        <pc:spChg chg="mod">
+          <ac:chgData name="Eder Silva" userId="9b7f41b4-798d-40cf-8f87-8e33ae7a0417" providerId="ADAL" clId="{DFF9E84E-5922-4F26-9EAD-8AB4E668133E}" dt="2026-10-30T20:19:52.601" v="1" actId="1076"/>
+          <ac:spMkLst>
+            <pc:docMk/>
+            <pc:sldMk cId="2133836751" sldId="333"/>
+            <ac:spMk id="2" creationId="{00000000-0000-0000-0000-000000000000}"/>
+          </ac:spMkLst>
+        </pc:spChg>
+      </pc:sldChg>
+      <pc:sldChg chg="modSp mod">
+        <pc:chgData name="Eder Silva" userId="9b7f41b4-798d-40cf-8f87-8e33ae7a0417" providerId="ADAL" clId="{DFF9E84E-5922-4F26-9EAD-8AB4E668133E}" dt="2026-10-30T20:20:19.991" v="43" actId="1035"/>
+        <pc:sldMkLst>
+          <pc:docMk/>
+          <pc:sldMk cId="105186291" sldId="335"/>
+        </pc:sldMkLst>
+        <pc:spChg chg="mod">
+          <ac:chgData name="Eder Silva" userId="9b7f41b4-798d-40cf-8f87-8e33ae7a0417" providerId="ADAL" clId="{DFF9E84E-5922-4F26-9EAD-8AB4E668133E}" dt="2026-10-30T20:20:03.011" v="3" actId="404"/>
+          <ac:spMkLst>
+            <pc:docMk/>
+            <pc:sldMk cId="105186291" sldId="335"/>
+            <ac:spMk id="3" creationId="{00000000-0000-0000-0000-000000000000}"/>
+          </ac:spMkLst>
+        </pc:spChg>
+        <pc:spChg chg="mod">
+          <ac:chgData name="Eder Silva" userId="9b7f41b4-798d-40cf-8f87-8e33ae7a0417" providerId="ADAL" clId="{DFF9E84E-5922-4F26-9EAD-8AB4E668133E}" dt="2026-10-30T20:20:19.991" v="43" actId="1035"/>
+          <ac:spMkLst>
+            <pc:docMk/>
+            <pc:sldMk cId="105186291" sldId="335"/>
+            <ac:spMk id="46" creationId="{C8960CF7-A989-9A32-59D3-53491C922FB9}"/>
+          </ac:spMkLst>
+        </pc:spChg>
+        <pc:spChg chg="mod">
+          <ac:chgData name="Eder Silva" userId="9b7f41b4-798d-40cf-8f87-8e33ae7a0417" providerId="ADAL" clId="{DFF9E84E-5922-4F26-9EAD-8AB4E668133E}" dt="2026-10-30T20:20:19.991" v="43" actId="1035"/>
+          <ac:spMkLst>
+            <pc:docMk/>
+            <pc:sldMk cId="105186291" sldId="335"/>
+            <ac:spMk id="47" creationId="{0DA81957-55F3-4EDE-6344-3D6808926561}"/>
+          </ac:spMkLst>
+        </pc:spChg>
+        <pc:spChg chg="mod">
+          <ac:chgData name="Eder Silva" userId="9b7f41b4-798d-40cf-8f87-8e33ae7a0417" providerId="ADAL" clId="{DFF9E84E-5922-4F26-9EAD-8AB4E668133E}" dt="2026-10-30T20:20:19.991" v="43" actId="1035"/>
+          <ac:spMkLst>
+            <pc:docMk/>
+            <pc:sldMk cId="105186291" sldId="335"/>
+            <ac:spMk id="48" creationId="{CF697353-6BB4-0295-C09E-86198860D38C}"/>
+          </ac:spMkLst>
+        </pc:spChg>
+        <pc:spChg chg="mod">
+          <ac:chgData name="Eder Silva" userId="9b7f41b4-798d-40cf-8f87-8e33ae7a0417" providerId="ADAL" clId="{DFF9E84E-5922-4F26-9EAD-8AB4E668133E}" dt="2026-10-30T20:20:19.991" v="43" actId="1035"/>
+          <ac:spMkLst>
+            <pc:docMk/>
+            <pc:sldMk cId="105186291" sldId="335"/>
+            <ac:spMk id="50" creationId="{765900ED-8CAA-4E28-5AEC-CE2E9F8F1F25}"/>
+          </ac:spMkLst>
+        </pc:spChg>
+        <pc:spChg chg="mod">
+          <ac:chgData name="Eder Silva" userId="9b7f41b4-798d-40cf-8f87-8e33ae7a0417" providerId="ADAL" clId="{DFF9E84E-5922-4F26-9EAD-8AB4E668133E}" dt="2026-10-30T20:20:19.991" v="43" actId="1035"/>
+          <ac:spMkLst>
+            <pc:docMk/>
+            <pc:sldMk cId="105186291" sldId="335"/>
+            <ac:spMk id="51" creationId="{EB8B451A-CB0A-28BB-EE07-6BFEC5EE0F7D}"/>
+          </ac:spMkLst>
+        </pc:spChg>
+        <pc:spChg chg="mod">
+          <ac:chgData name="Eder Silva" userId="9b7f41b4-798d-40cf-8f87-8e33ae7a0417" providerId="ADAL" clId="{DFF9E84E-5922-4F26-9EAD-8AB4E668133E}" dt="2026-10-30T20:20:19.991" v="43" actId="1035"/>
+          <ac:spMkLst>
+            <pc:docMk/>
+            <pc:sldMk cId="105186291" sldId="335"/>
+            <ac:spMk id="52" creationId="{C271BAEE-1AAA-A317-F2B0-9862E83DC638}"/>
+          </ac:spMkLst>
+        </pc:spChg>
+        <pc:spChg chg="mod">
+          <ac:chgData name="Eder Silva" userId="9b7f41b4-798d-40cf-8f87-8e33ae7a0417" providerId="ADAL" clId="{DFF9E84E-5922-4F26-9EAD-8AB4E668133E}" dt="2026-10-30T20:20:19.991" v="43" actId="1035"/>
+          <ac:spMkLst>
+            <pc:docMk/>
+            <pc:sldMk cId="105186291" sldId="335"/>
+            <ac:spMk id="53" creationId="{989AF5DA-0C37-A8B0-2243-B74AFB79C596}"/>
+          </ac:spMkLst>
+        </pc:spChg>
+        <pc:spChg chg="mod">
+          <ac:chgData name="Eder Silva" userId="9b7f41b4-798d-40cf-8f87-8e33ae7a0417" providerId="ADAL" clId="{DFF9E84E-5922-4F26-9EAD-8AB4E668133E}" dt="2026-10-30T20:20:19.991" v="43" actId="1035"/>
+          <ac:spMkLst>
+            <pc:docMk/>
+            <pc:sldMk cId="105186291" sldId="335"/>
+            <ac:spMk id="54" creationId="{D606C15F-1D7C-A6FF-4CA9-117F9A3284E4}"/>
+          </ac:spMkLst>
+        </pc:spChg>
+        <pc:spChg chg="mod">
+          <ac:chgData name="Eder Silva" userId="9b7f41b4-798d-40cf-8f87-8e33ae7a0417" providerId="ADAL" clId="{DFF9E84E-5922-4F26-9EAD-8AB4E668133E}" dt="2026-10-30T20:20:19.991" v="43" actId="1035"/>
+          <ac:spMkLst>
+            <pc:docMk/>
+            <pc:sldMk cId="105186291" sldId="335"/>
+            <ac:spMk id="55" creationId="{936CE3BE-1D42-95CF-63FC-9C594D96D1FD}"/>
+          </ac:spMkLst>
+        </pc:spChg>
+        <pc:spChg chg="mod">
+          <ac:chgData name="Eder Silva" userId="9b7f41b4-798d-40cf-8f87-8e33ae7a0417" providerId="ADAL" clId="{DFF9E84E-5922-4F26-9EAD-8AB4E668133E}" dt="2026-10-30T20:20:09.251" v="8" actId="1036"/>
+          <ac:spMkLst>
+            <pc:docMk/>
+            <pc:sldMk cId="105186291" sldId="335"/>
+            <ac:spMk id="56" creationId="{106D9384-6ABF-2EB6-AEA2-D3F229854ED4}"/>
+          </ac:spMkLst>
+        </pc:spChg>
+        <pc:spChg chg="mod">
+          <ac:chgData name="Eder Silva" userId="9b7f41b4-798d-40cf-8f87-8e33ae7a0417" providerId="ADAL" clId="{DFF9E84E-5922-4F26-9EAD-8AB4E668133E}" dt="2026-10-30T20:20:09.251" v="8" actId="1036"/>
+          <ac:spMkLst>
+            <pc:docMk/>
+            <pc:sldMk cId="105186291" sldId="335"/>
+            <ac:spMk id="57" creationId="{78B82DA2-4CE9-D71B-3525-59EBDD993893}"/>
+          </ac:spMkLst>
+        </pc:spChg>
+        <pc:spChg chg="mod">
+          <ac:chgData name="Eder Silva" userId="9b7f41b4-798d-40cf-8f87-8e33ae7a0417" providerId="ADAL" clId="{DFF9E84E-5922-4F26-9EAD-8AB4E668133E}" dt="2026-10-30T20:20:09.251" v="8" actId="1036"/>
+          <ac:spMkLst>
+            <pc:docMk/>
+            <pc:sldMk cId="105186291" sldId="335"/>
+            <ac:spMk id="58" creationId="{5674CF70-1C45-DB5E-BB20-6C917E1023C5}"/>
+          </ac:spMkLst>
+        </pc:spChg>
+        <pc:spChg chg="mod">
+          <ac:chgData name="Eder Silva" userId="9b7f41b4-798d-40cf-8f87-8e33ae7a0417" providerId="ADAL" clId="{DFF9E84E-5922-4F26-9EAD-8AB4E668133E}" dt="2026-10-30T20:20:19.991" v="43" actId="1035"/>
+          <ac:spMkLst>
+            <pc:docMk/>
+            <pc:sldMk cId="105186291" sldId="335"/>
+            <ac:spMk id="59" creationId="{203D26A4-028F-E527-8BA1-A733F48964C0}"/>
+          </ac:spMkLst>
+        </pc:spChg>
+      </pc:sldChg>
+      <pc:sldChg chg="modSp">
+        <pc:chgData name="Eder Silva" userId="9b7f41b4-798d-40cf-8f87-8e33ae7a0417" providerId="ADAL" clId="{DFF9E84E-5922-4F26-9EAD-8AB4E668133E}" dt="2026-10-30T20:20:29.401" v="66" actId="1036"/>
+        <pc:sldMkLst>
+          <pc:docMk/>
+          <pc:sldMk cId="2154438909" sldId="336"/>
+        </pc:sldMkLst>
+        <pc:spChg chg="mod">
+          <ac:chgData name="Eder Silva" userId="9b7f41b4-798d-40cf-8f87-8e33ae7a0417" providerId="ADAL" clId="{DFF9E84E-5922-4F26-9EAD-8AB4E668133E}" dt="2026-10-30T20:20:29.401" v="66" actId="1036"/>
+          <ac:spMkLst>
+            <pc:docMk/>
+            <pc:sldMk cId="2154438909" sldId="336"/>
+            <ac:spMk id="13" creationId="{7E6977EF-71C9-4239-BFE1-6304E1616879}"/>
+          </ac:spMkLst>
+        </pc:spChg>
+        <pc:spChg chg="mod">
+          <ac:chgData name="Eder Silva" userId="9b7f41b4-798d-40cf-8f87-8e33ae7a0417" providerId="ADAL" clId="{DFF9E84E-5922-4F26-9EAD-8AB4E668133E}" dt="2026-10-30T20:20:29.401" v="66" actId="1036"/>
+          <ac:spMkLst>
+            <pc:docMk/>
+            <pc:sldMk cId="2154438909" sldId="336"/>
+            <ac:spMk id="14" creationId="{9AB7BDBE-A5B3-D4D9-7787-186CC7264287}"/>
+          </ac:spMkLst>
+        </pc:spChg>
+        <pc:spChg chg="mod">
+          <ac:chgData name="Eder Silva" userId="9b7f41b4-798d-40cf-8f87-8e33ae7a0417" providerId="ADAL" clId="{DFF9E84E-5922-4F26-9EAD-8AB4E668133E}" dt="2026-10-30T20:20:29.401" v="66" actId="1036"/>
+          <ac:spMkLst>
+            <pc:docMk/>
+            <pc:sldMk cId="2154438909" sldId="336"/>
+            <ac:spMk id="15" creationId="{653A728D-3AA2-972C-0D58-99E5B23B77D2}"/>
+          </ac:spMkLst>
+        </pc:spChg>
+      </pc:sldChg>
+      <pc:sldChg chg="modSp mod">
+        <pc:chgData name="Eder Silva" userId="9b7f41b4-798d-40cf-8f87-8e33ae7a0417" providerId="ADAL" clId="{DFF9E84E-5922-4F26-9EAD-8AB4E668133E}" dt="2026-10-30T20:16:51.890" v="0" actId="14100"/>
+        <pc:sldMkLst>
+          <pc:docMk/>
+          <pc:sldMk cId="595962341" sldId="337"/>
+        </pc:sldMkLst>
+        <pc:spChg chg="mod">
+          <ac:chgData name="Eder Silva" userId="9b7f41b4-798d-40cf-8f87-8e33ae7a0417" providerId="ADAL" clId="{DFF9E84E-5922-4F26-9EAD-8AB4E668133E}" dt="2026-10-30T20:16:51.890" v="0" actId="14100"/>
+          <ac:spMkLst>
+            <pc:docMk/>
+            <pc:sldMk cId="595962341" sldId="337"/>
+            <ac:spMk id="3" creationId="{00000000-0000-0000-0000-000000000000}"/>
+          </ac:spMkLst>
+        </pc:spChg>
+      </pc:sldChg>
+      <pc:sldChg chg="modSp mod">
+        <pc:chgData name="Eder Silva" userId="9b7f41b4-798d-40cf-8f87-8e33ae7a0417" providerId="ADAL" clId="{DFF9E84E-5922-4F26-9EAD-8AB4E668133E}" dt="2026-10-30T20:20:41.574" v="67" actId="1076"/>
+        <pc:sldMkLst>
+          <pc:docMk/>
+          <pc:sldMk cId="2483332524" sldId="339"/>
+        </pc:sldMkLst>
+        <pc:spChg chg="mod">
+          <ac:chgData name="Eder Silva" userId="9b7f41b4-798d-40cf-8f87-8e33ae7a0417" providerId="ADAL" clId="{DFF9E84E-5922-4F26-9EAD-8AB4E668133E}" dt="2026-10-30T20:20:41.574" v="67" actId="1076"/>
+          <ac:spMkLst>
+            <pc:docMk/>
+            <pc:sldMk cId="2483332524" sldId="339"/>
+            <ac:spMk id="2" creationId="{00000000-0000-0000-0000-000000000000}"/>
+          </ac:spMkLst>
+        </pc:spChg>
+      </pc:sldChg>
+      <pc:sldChg chg="modSp">
+        <pc:chgData name="Eder Silva" userId="9b7f41b4-798d-40cf-8f87-8e33ae7a0417" providerId="ADAL" clId="{DFF9E84E-5922-4F26-9EAD-8AB4E668133E}" dt="2026-10-30T20:20:57.348" v="97" actId="1036"/>
+        <pc:sldMkLst>
+          <pc:docMk/>
+          <pc:sldMk cId="2365079101" sldId="342"/>
+        </pc:sldMkLst>
+        <pc:spChg chg="mod">
+          <ac:chgData name="Eder Silva" userId="9b7f41b4-798d-40cf-8f87-8e33ae7a0417" providerId="ADAL" clId="{DFF9E84E-5922-4F26-9EAD-8AB4E668133E}" dt="2026-10-30T20:20:49.453" v="68" actId="1036"/>
+          <ac:spMkLst>
+            <pc:docMk/>
+            <pc:sldMk cId="2365079101" sldId="342"/>
+            <ac:spMk id="12" creationId="{00000000-0000-0000-0000-000000000000}"/>
+          </ac:spMkLst>
+        </pc:spChg>
+        <pc:spChg chg="mod">
+          <ac:chgData name="Eder Silva" userId="9b7f41b4-798d-40cf-8f87-8e33ae7a0417" providerId="ADAL" clId="{DFF9E84E-5922-4F26-9EAD-8AB4E668133E}" dt="2026-10-30T20:20:57.348" v="97" actId="1036"/>
+          <ac:spMkLst>
+            <pc:docMk/>
+            <pc:sldMk cId="2365079101" sldId="342"/>
+            <ac:spMk id="13" creationId="{3D71D329-9393-DB25-B597-2E88F12CFD3C}"/>
+          </ac:spMkLst>
+        </pc:spChg>
+        <pc:spChg chg="mod">
+          <ac:chgData name="Eder Silva" userId="9b7f41b4-798d-40cf-8f87-8e33ae7a0417" providerId="ADAL" clId="{DFF9E84E-5922-4F26-9EAD-8AB4E668133E}" dt="2026-10-30T20:20:57.348" v="97" actId="1036"/>
+          <ac:spMkLst>
+            <pc:docMk/>
+            <pc:sldMk cId="2365079101" sldId="342"/>
+            <ac:spMk id="14" creationId="{D76D3013-1171-16C2-0719-4C3135B5AEA2}"/>
+          </ac:spMkLst>
+        </pc:spChg>
+        <pc:spChg chg="mod">
+          <ac:chgData name="Eder Silva" userId="9b7f41b4-798d-40cf-8f87-8e33ae7a0417" providerId="ADAL" clId="{DFF9E84E-5922-4F26-9EAD-8AB4E668133E}" dt="2026-10-30T20:20:57.348" v="97" actId="1036"/>
+          <ac:spMkLst>
+            <pc:docMk/>
+            <pc:sldMk cId="2365079101" sldId="342"/>
+            <ac:spMk id="15" creationId="{23100294-7F91-9174-7CB7-AD817241E673}"/>
+          </ac:spMkLst>
+        </pc:spChg>
+      </pc:sldChg>
+      <pc:sldChg chg="modSp mod">
+        <pc:chgData name="Eder Silva" userId="9b7f41b4-798d-40cf-8f87-8e33ae7a0417" providerId="ADAL" clId="{DFF9E84E-5922-4F26-9EAD-8AB4E668133E}" dt="2026-10-30T20:21:11.171" v="121" actId="1076"/>
+        <pc:sldMkLst>
+          <pc:docMk/>
+          <pc:sldMk cId="351842598" sldId="343"/>
+        </pc:sldMkLst>
+        <pc:spChg chg="mod">
+          <ac:chgData name="Eder Silva" userId="9b7f41b4-798d-40cf-8f87-8e33ae7a0417" providerId="ADAL" clId="{DFF9E84E-5922-4F26-9EAD-8AB4E668133E}" dt="2026-10-30T20:21:11.171" v="121" actId="1076"/>
+          <ac:spMkLst>
+            <pc:docMk/>
+            <pc:sldMk cId="351842598" sldId="343"/>
+            <ac:spMk id="13" creationId="{2AE8F0D3-3F44-B662-F402-1DCD1713CA5A}"/>
+          </ac:spMkLst>
+        </pc:spChg>
+        <pc:spChg chg="mod">
+          <ac:chgData name="Eder Silva" userId="9b7f41b4-798d-40cf-8f87-8e33ae7a0417" providerId="ADAL" clId="{DFF9E84E-5922-4F26-9EAD-8AB4E668133E}" dt="2026-10-30T20:21:05.703" v="120" actId="1036"/>
+          <ac:spMkLst>
+            <pc:docMk/>
+            <pc:sldMk cId="351842598" sldId="343"/>
+            <ac:spMk id="15" creationId="{97F33EEC-4329-FC61-DF6F-3AFA41496795}"/>
+          </ac:spMkLst>
+        </pc:spChg>
+        <pc:graphicFrameChg chg="mod">
+          <ac:chgData name="Eder Silva" userId="9b7f41b4-798d-40cf-8f87-8e33ae7a0417" providerId="ADAL" clId="{DFF9E84E-5922-4F26-9EAD-8AB4E668133E}" dt="2026-10-30T20:21:05.703" v="120" actId="1036"/>
+          <ac:graphicFrameMkLst>
+            <pc:docMk/>
+            <pc:sldMk cId="351842598" sldId="343"/>
+            <ac:graphicFrameMk id="14" creationId="{A4CD70E9-7ABD-277A-3AB3-E64146B90D05}"/>
+          </ac:graphicFrameMkLst>
+        </pc:graphicFrameChg>
+      </pc:sldChg>
+      <pc:sldChg chg="modSp">
+        <pc:chgData name="Eder Silva" userId="9b7f41b4-798d-40cf-8f87-8e33ae7a0417" providerId="ADAL" clId="{DFF9E84E-5922-4F26-9EAD-8AB4E668133E}" dt="2026-10-30T20:21:27.671" v="142" actId="1036"/>
+        <pc:sldMkLst>
+          <pc:docMk/>
+          <pc:sldMk cId="1180430826" sldId="349"/>
+        </pc:sldMkLst>
+        <pc:spChg chg="mod">
+          <ac:chgData name="Eder Silva" userId="9b7f41b4-798d-40cf-8f87-8e33ae7a0417" providerId="ADAL" clId="{DFF9E84E-5922-4F26-9EAD-8AB4E668133E}" dt="2026-10-30T20:21:27.671" v="142" actId="1036"/>
+          <ac:spMkLst>
+            <pc:docMk/>
+            <pc:sldMk cId="1180430826" sldId="349"/>
+            <ac:spMk id="13" creationId="{24668A43-F66A-B47A-05BB-D7854408F7DE}"/>
+          </ac:spMkLst>
+        </pc:spChg>
+        <pc:spChg chg="mod">
+          <ac:chgData name="Eder Silva" userId="9b7f41b4-798d-40cf-8f87-8e33ae7a0417" providerId="ADAL" clId="{DFF9E84E-5922-4F26-9EAD-8AB4E668133E}" dt="2026-10-30T20:21:27.671" v="142" actId="1036"/>
+          <ac:spMkLst>
+            <pc:docMk/>
+            <pc:sldMk cId="1180430826" sldId="349"/>
+            <ac:spMk id="14" creationId="{5A1237D0-3C3D-F48F-0E40-8099EE4F7ED5}"/>
+          </ac:spMkLst>
+        </pc:spChg>
+        <pc:spChg chg="mod">
+          <ac:chgData name="Eder Silva" userId="9b7f41b4-798d-40cf-8f87-8e33ae7a0417" providerId="ADAL" clId="{DFF9E84E-5922-4F26-9EAD-8AB4E668133E}" dt="2026-10-30T20:21:27.671" v="142" actId="1036"/>
+          <ac:spMkLst>
+            <pc:docMk/>
+            <pc:sldMk cId="1180430826" sldId="349"/>
+            <ac:spMk id="15" creationId="{7FA45D52-58B0-5EA6-939B-3E1A6CB85100}"/>
+          </ac:spMkLst>
+        </pc:spChg>
+      </pc:sldChg>
+      <pc:sldChg chg="modSp mod">
+        <pc:chgData name="Eder Silva" userId="9b7f41b4-798d-40cf-8f87-8e33ae7a0417" providerId="ADAL" clId="{DFF9E84E-5922-4F26-9EAD-8AB4E668133E}" dt="2026-10-30T20:21:37.794" v="143" actId="1076"/>
+        <pc:sldMkLst>
+          <pc:docMk/>
+          <pc:sldMk cId="2606867720" sldId="353"/>
+        </pc:sldMkLst>
+        <pc:spChg chg="mod">
+          <ac:chgData name="Eder Silva" userId="9b7f41b4-798d-40cf-8f87-8e33ae7a0417" providerId="ADAL" clId="{DFF9E84E-5922-4F26-9EAD-8AB4E668133E}" dt="2026-10-30T20:21:37.794" v="143" actId="1076"/>
+          <ac:spMkLst>
+            <pc:docMk/>
+            <pc:sldMk cId="2606867720" sldId="353"/>
+            <ac:spMk id="2" creationId="{00000000-0000-0000-0000-000000000000}"/>
+          </ac:spMkLst>
+        </pc:spChg>
+      </pc:sldChg>
+      <pc:sldChg chg="modSp mod">
+        <pc:chgData name="Eder Silva" userId="9b7f41b4-798d-40cf-8f87-8e33ae7a0417" providerId="ADAL" clId="{DFF9E84E-5922-4F26-9EAD-8AB4E668133E}" dt="2026-10-30T20:21:51.941" v="168" actId="1035"/>
+        <pc:sldMkLst>
+          <pc:docMk/>
+          <pc:sldMk cId="3362587768" sldId="365"/>
+        </pc:sldMkLst>
+        <pc:graphicFrameChg chg="mod">
+          <ac:chgData name="Eder Silva" userId="9b7f41b4-798d-40cf-8f87-8e33ae7a0417" providerId="ADAL" clId="{DFF9E84E-5922-4F26-9EAD-8AB4E668133E}" dt="2026-10-30T20:21:51.941" v="168" actId="1035"/>
+          <ac:graphicFrameMkLst>
+            <pc:docMk/>
+            <pc:sldMk cId="3362587768" sldId="365"/>
+            <ac:graphicFrameMk id="13" creationId="{9690DA48-C136-DC4A-9750-4F84A249C02D}"/>
+          </ac:graphicFrameMkLst>
+        </pc:graphicFrameChg>
+      </pc:sldChg>
+      <pc:sldChg chg="modSp">
+        <pc:chgData name="Eder Silva" userId="9b7f41b4-798d-40cf-8f87-8e33ae7a0417" providerId="ADAL" clId="{DFF9E84E-5922-4F26-9EAD-8AB4E668133E}" dt="2026-10-30T20:22:00.247" v="190" actId="1036"/>
+        <pc:sldMkLst>
+          <pc:docMk/>
+          <pc:sldMk cId="3011081041" sldId="368"/>
+        </pc:sldMkLst>
+        <pc:spChg chg="mod">
+          <ac:chgData name="Eder Silva" userId="9b7f41b4-798d-40cf-8f87-8e33ae7a0417" providerId="ADAL" clId="{DFF9E84E-5922-4F26-9EAD-8AB4E668133E}" dt="2026-10-30T20:22:00.247" v="190" actId="1036"/>
+          <ac:spMkLst>
+            <pc:docMk/>
+            <pc:sldMk cId="3011081041" sldId="368"/>
+            <ac:spMk id="13" creationId="{239D714E-4A9E-49F4-4C6F-02F3D595C8A3}"/>
+          </ac:spMkLst>
+        </pc:spChg>
+        <pc:spChg chg="mod">
+          <ac:chgData name="Eder Silva" userId="9b7f41b4-798d-40cf-8f87-8e33ae7a0417" providerId="ADAL" clId="{DFF9E84E-5922-4F26-9EAD-8AB4E668133E}" dt="2026-10-30T20:22:00.247" v="190" actId="1036"/>
+          <ac:spMkLst>
+            <pc:docMk/>
+            <pc:sldMk cId="3011081041" sldId="368"/>
+            <ac:spMk id="14" creationId="{932B0731-8007-D7B0-FA6A-08AF1B041478}"/>
+          </ac:spMkLst>
+        </pc:spChg>
+        <pc:spChg chg="mod">
+          <ac:chgData name="Eder Silva" userId="9b7f41b4-798d-40cf-8f87-8e33ae7a0417" providerId="ADAL" clId="{DFF9E84E-5922-4F26-9EAD-8AB4E668133E}" dt="2026-10-30T20:22:00.247" v="190" actId="1036"/>
+          <ac:spMkLst>
+            <pc:docMk/>
+            <pc:sldMk cId="3011081041" sldId="368"/>
+            <ac:spMk id="15" creationId="{6FE0513F-7082-AEE1-9BB5-4A41CEC3CA41}"/>
+          </ac:spMkLst>
+        </pc:spChg>
+        <pc:spChg chg="mod">
+          <ac:chgData name="Eder Silva" userId="9b7f41b4-798d-40cf-8f87-8e33ae7a0417" providerId="ADAL" clId="{DFF9E84E-5922-4F26-9EAD-8AB4E668133E}" dt="2026-10-30T20:22:00.247" v="190" actId="1036"/>
+          <ac:spMkLst>
+            <pc:docMk/>
+            <pc:sldMk cId="3011081041" sldId="368"/>
+            <ac:spMk id="16" creationId="{4E54A616-D7DC-EAF3-1083-D5987FDA56C8}"/>
+          </ac:spMkLst>
+        </pc:spChg>
+      </pc:sldChg>
+      <pc:sldChg chg="modSp mod">
+        <pc:chgData name="Eder Silva" userId="9b7f41b4-798d-40cf-8f87-8e33ae7a0417" providerId="ADAL" clId="{DFF9E84E-5922-4F26-9EAD-8AB4E668133E}" dt="2026-10-30T20:22:07.574" v="211" actId="1036"/>
+        <pc:sldMkLst>
+          <pc:docMk/>
+          <pc:sldMk cId="2807703547" sldId="370"/>
+        </pc:sldMkLst>
+        <pc:spChg chg="mod">
+          <ac:chgData name="Eder Silva" userId="9b7f41b4-798d-40cf-8f87-8e33ae7a0417" providerId="ADAL" clId="{DFF9E84E-5922-4F26-9EAD-8AB4E668133E}" dt="2026-10-30T20:22:07.574" v="211" actId="1036"/>
+          <ac:spMkLst>
+            <pc:docMk/>
+            <pc:sldMk cId="2807703547" sldId="370"/>
+            <ac:spMk id="13" creationId="{C032F987-80C8-410C-9B58-B9D724167CAF}"/>
+          </ac:spMkLst>
+        </pc:spChg>
+        <pc:spChg chg="mod">
+          <ac:chgData name="Eder Silva" userId="9b7f41b4-798d-40cf-8f87-8e33ae7a0417" providerId="ADAL" clId="{DFF9E84E-5922-4F26-9EAD-8AB4E668133E}" dt="2026-10-30T20:22:07.574" v="211" actId="1036"/>
+          <ac:spMkLst>
+            <pc:docMk/>
+            <pc:sldMk cId="2807703547" sldId="370"/>
+            <ac:spMk id="14" creationId="{68FAE380-AE7E-FB33-989F-A9CE6887F7F4}"/>
+          </ac:spMkLst>
+        </pc:spChg>
+      </pc:sldChg>
+      <pc:sldChg chg="modSp mod">
+        <pc:chgData name="Eder Silva" userId="9b7f41b4-798d-40cf-8f87-8e33ae7a0417" providerId="ADAL" clId="{DFF9E84E-5922-4F26-9EAD-8AB4E668133E}" dt="2026-10-30T20:22:14.666" v="212" actId="1076"/>
+        <pc:sldMkLst>
+          <pc:docMk/>
+          <pc:sldMk cId="2158595547" sldId="371"/>
+        </pc:sldMkLst>
+        <pc:spChg chg="mod">
+          <ac:chgData name="Eder Silva" userId="9b7f41b4-798d-40cf-8f87-8e33ae7a0417" providerId="ADAL" clId="{DFF9E84E-5922-4F26-9EAD-8AB4E668133E}" dt="2026-10-30T20:22:14.666" v="212" actId="1076"/>
+          <ac:spMkLst>
+            <pc:docMk/>
+            <pc:sldMk cId="2158595547" sldId="371"/>
+            <ac:spMk id="2" creationId="{00000000-0000-0000-0000-000000000000}"/>
+          </ac:spMkLst>
+        </pc:spChg>
+      </pc:sldChg>
+      <pc:sldChg chg="modSp mod">
+        <pc:chgData name="Eder Silva" userId="9b7f41b4-798d-40cf-8f87-8e33ae7a0417" providerId="ADAL" clId="{DFF9E84E-5922-4F26-9EAD-8AB4E668133E}" dt="2026-10-30T20:22:34.888" v="213" actId="1076"/>
+        <pc:sldMkLst>
+          <pc:docMk/>
+          <pc:sldMk cId="2477541534" sldId="382"/>
+        </pc:sldMkLst>
+        <pc:spChg chg="mod">
+          <ac:chgData name="Eder Silva" userId="9b7f41b4-798d-40cf-8f87-8e33ae7a0417" providerId="ADAL" clId="{DFF9E84E-5922-4F26-9EAD-8AB4E668133E}" dt="2026-10-30T20:22:34.888" v="213" actId="1076"/>
+          <ac:spMkLst>
+            <pc:docMk/>
+            <pc:sldMk cId="2477541534" sldId="382"/>
+            <ac:spMk id="13" creationId="{1F7E2DB0-86A8-7FB1-C096-04AB9253F216}"/>
+          </ac:spMkLst>
+        </pc:spChg>
+      </pc:sldChg>
+    </pc:docChg>
+  </pc:docChgLst>
+</pc:chgInfo>
 </file>
 
 <file path=ppt/notesMasters/notesMaster1.xml><?xml version="1.0" encoding="utf-8"?>
@@ -5648,7 +6080,7 @@
           <a:p>
             <a:fld id="{5BCAD085-E8A6-8845-BD4E-CB4CCA059FC4}" type="datetimeFigureOut">
               <a:rPr lang="en-US" smtClean="0"/>
-              <a:t>10/27/2026</a:t>
+              <a:t>10/30/2026</a:t>
             </a:fld>
             <a:endParaRPr lang="en-US"/>
           </a:p>
@@ -5816,7 +6248,7 @@
           <a:p>
             <a:fld id="{5BCAD085-E8A6-8845-BD4E-CB4CCA059FC4}" type="datetimeFigureOut">
               <a:rPr lang="en-US" smtClean="0"/>
-              <a:t>10/27/2026</a:t>
+              <a:t>10/30/2026</a:t>
             </a:fld>
             <a:endParaRPr lang="en-US"/>
           </a:p>
@@ -5994,7 +6426,7 @@
           <a:p>
             <a:fld id="{5BCAD085-E8A6-8845-BD4E-CB4CCA059FC4}" type="datetimeFigureOut">
               <a:rPr lang="en-US" smtClean="0"/>
-              <a:t>10/27/2026</a:t>
+              <a:t>10/30/2026</a:t>
             </a:fld>
             <a:endParaRPr lang="en-US"/>
           </a:p>
@@ -6162,7 +6594,7 @@
           <a:p>
             <a:fld id="{5BCAD085-E8A6-8845-BD4E-CB4CCA059FC4}" type="datetimeFigureOut">
               <a:rPr lang="en-US" smtClean="0"/>
-              <a:t>10/27/2026</a:t>
+              <a:t>10/30/2026</a:t>
             </a:fld>
             <a:endParaRPr lang="en-US"/>
           </a:p>
@@ -6407,7 +6839,7 @@
           <a:p>
             <a:fld id="{5BCAD085-E8A6-8845-BD4E-CB4CCA059FC4}" type="datetimeFigureOut">
               <a:rPr lang="en-US" smtClean="0"/>
-              <a:t>10/27/2026</a:t>
+              <a:t>10/30/2026</a:t>
             </a:fld>
             <a:endParaRPr lang="en-US"/>
           </a:p>
@@ -6692,7 +7124,7 @@
           <a:p>
             <a:fld id="{5BCAD085-E8A6-8845-BD4E-CB4CCA059FC4}" type="datetimeFigureOut">
               <a:rPr lang="en-US" smtClean="0"/>
-              <a:t>10/27/2026</a:t>
+              <a:t>10/30/2026</a:t>
             </a:fld>
             <a:endParaRPr lang="en-US"/>
           </a:p>
@@ -7111,7 +7543,7 @@
           <a:p>
             <a:fld id="{5BCAD085-E8A6-8845-BD4E-CB4CCA059FC4}" type="datetimeFigureOut">
               <a:rPr lang="en-US" smtClean="0"/>
-              <a:t>10/27/2026</a:t>
+              <a:t>10/30/2026</a:t>
             </a:fld>
             <a:endParaRPr lang="en-US"/>
           </a:p>
@@ -7228,7 +7660,7 @@
           <a:p>
             <a:fld id="{5BCAD085-E8A6-8845-BD4E-CB4CCA059FC4}" type="datetimeFigureOut">
               <a:rPr lang="en-US" smtClean="0"/>
-              <a:t>10/27/2026</a:t>
+              <a:t>10/30/2026</a:t>
             </a:fld>
             <a:endParaRPr lang="en-US"/>
           </a:p>
@@ -7323,7 +7755,7 @@
           <a:p>
             <a:fld id="{5BCAD085-E8A6-8845-BD4E-CB4CCA059FC4}" type="datetimeFigureOut">
               <a:rPr lang="en-US" smtClean="0"/>
-              <a:t>10/27/2026</a:t>
+              <a:t>10/30/2026</a:t>
             </a:fld>
             <a:endParaRPr lang="en-US"/>
           </a:p>
@@ -7598,7 +8030,7 @@
           <a:p>
             <a:fld id="{5BCAD085-E8A6-8845-BD4E-CB4CCA059FC4}" type="datetimeFigureOut">
               <a:rPr lang="en-US" smtClean="0"/>
-              <a:t>10/27/2026</a:t>
+              <a:t>10/30/2026</a:t>
             </a:fld>
             <a:endParaRPr lang="en-US"/>
           </a:p>
@@ -7850,7 +8282,7 @@
           <a:p>
             <a:fld id="{5BCAD085-E8A6-8845-BD4E-CB4CCA059FC4}" type="datetimeFigureOut">
               <a:rPr lang="en-US" smtClean="0"/>
-              <a:t>10/27/2026</a:t>
+              <a:t>10/30/2026</a:t>
             </a:fld>
             <a:endParaRPr lang="en-US"/>
           </a:p>
@@ -8061,7 +8493,7 @@
           <a:p>
             <a:fld id="{5BCAD085-E8A6-8845-BD4E-CB4CCA059FC4}" type="datetimeFigureOut">
               <a:rPr lang="en-US" smtClean="0"/>
-              <a:t>10/27/2026</a:t>
+              <a:t>10/30/2026</a:t>
             </a:fld>
             <a:endParaRPr lang="en-US"/>
           </a:p>
@@ -8864,7 +9296,7 @@
         </p:nvGraphicFramePr>
         <p:xfrm>
           <a:off x="640080" y="1053211"/>
-          <a:ext cx="10909300" cy="2032000"/>
+          <a:ext cx="10909300" cy="2993390"/>
         </p:xfrm>
         <a:graphic>
           <a:graphicData uri="http://schemas.openxmlformats.org/drawingml/2006/table">
@@ -11443,7 +11875,7 @@
         </p:nvSpPr>
         <p:spPr>
           <a:xfrm>
-            <a:off x="502920" y="6144768"/>
+            <a:off x="502920" y="6151118"/>
             <a:ext cx="11201400" cy="258725"/>
           </a:xfrm>
           <a:prstGeom prst="rect">
@@ -11494,7 +11926,7 @@
         </p:nvSpPr>
         <p:spPr>
           <a:xfrm>
-            <a:off x="640080" y="1053211"/>
+            <a:off x="640080" y="1453261"/>
             <a:ext cx="10909300" cy="2156460"/>
           </a:xfrm>
           <a:prstGeom prst="roundRect">
@@ -11703,7 +12135,7 @@
         </p:nvSpPr>
         <p:spPr>
           <a:xfrm>
-            <a:off x="640080" y="1053211"/>
+            <a:off x="640080" y="1453261"/>
             <a:ext cx="76200" cy="2156460"/>
           </a:xfrm>
           <a:prstGeom prst="rect">
@@ -11774,7 +12206,7 @@
         </p:nvSpPr>
         <p:spPr>
           <a:xfrm>
-            <a:off x="640080" y="3362071"/>
+            <a:off x="640080" y="3762121"/>
             <a:ext cx="10909300" cy="1350264"/>
           </a:xfrm>
           <a:prstGeom prst="rect">
@@ -12135,7 +12567,7 @@
         </p:nvSpPr>
         <p:spPr>
           <a:xfrm>
-            <a:off x="640080" y="1053210"/>
+            <a:off x="570230" y="1822069"/>
             <a:ext cx="10909300" cy="356616"/>
           </a:xfrm>
           <a:prstGeom prst="rect">
@@ -12155,7 +12587,7 @@
               </a:lnSpc>
             </a:pPr>
             <a:r>
-              <a:rPr lang="pt-BR" sz="2000" b="1">
+              <a:rPr lang="pt-BR" sz="2000" b="1" dirty="0">
                 <a:solidFill>
                   <a:srgbClr val="4A7C59"/>
                 </a:solidFill>
@@ -12163,7 +12595,7 @@
               </a:rPr>
               <a:t>Tabela "larga" (uma linha por parcela, tudo junto):</a:t>
             </a:r>
-            <a:endParaRPr lang="en-US" sz="2000" b="1">
+            <a:endParaRPr lang="en-US" sz="2000" b="1" dirty="0">
               <a:solidFill>
                 <a:srgbClr val="4A7C59"/>
               </a:solidFill>
@@ -12187,14 +12619,14 @@
           <p:nvPr>
             <p:extLst>
               <p:ext uri="{D42A27DB-BD31-4B8C-83A1-F6EECF244321}">
-                <p14:modId xmlns:p14="http://schemas.microsoft.com/office/powerpoint/2010/main" val="3703774802"/>
+                <p14:modId xmlns:p14="http://schemas.microsoft.com/office/powerpoint/2010/main" val="841253509"/>
               </p:ext>
             </p:extLst>
           </p:nvPr>
         </p:nvGraphicFramePr>
         <p:xfrm>
-          <a:off x="640080" y="1562226"/>
-          <a:ext cx="10909300" cy="762000"/>
+          <a:off x="640080" y="2152776"/>
+          <a:ext cx="10896600" cy="943737"/>
         </p:xfrm>
         <a:graphic>
           <a:graphicData uri="http://schemas.openxmlformats.org/drawingml/2006/table">
@@ -13091,7 +13523,7 @@
         </p:nvSpPr>
         <p:spPr>
           <a:xfrm>
-            <a:off x="640080" y="2658362"/>
+            <a:off x="640080" y="3248912"/>
             <a:ext cx="10909300" cy="1783080"/>
           </a:xfrm>
           <a:prstGeom prst="rect">
@@ -15281,7 +15713,7 @@
         </p:nvGraphicFramePr>
         <p:xfrm>
           <a:off x="640080" y="3339211"/>
-          <a:ext cx="10909300" cy="1016000"/>
+          <a:ext cx="10896600" cy="1258316"/>
         </p:xfrm>
         <a:graphic>
           <a:graphicData uri="http://schemas.openxmlformats.org/drawingml/2006/table">
@@ -16307,7 +16739,7 @@
         </p:nvGraphicFramePr>
         <p:xfrm>
           <a:off x="640080" y="4104259"/>
-          <a:ext cx="10909300" cy="762000"/>
+          <a:ext cx="10909300" cy="943737"/>
         </p:xfrm>
         <a:graphic>
           <a:graphicData uri="http://schemas.openxmlformats.org/drawingml/2006/table">
@@ -17020,7 +17452,7 @@
         </p:nvGraphicFramePr>
         <p:xfrm>
           <a:off x="640080" y="2882011"/>
-          <a:ext cx="10909300" cy="1016000"/>
+          <a:ext cx="10909300" cy="1258316"/>
         </p:xfrm>
         <a:graphic>
           <a:graphicData uri="http://schemas.openxmlformats.org/drawingml/2006/table">
@@ -17957,7 +18389,7 @@
         </p:nvSpPr>
         <p:spPr>
           <a:xfrm>
-            <a:off x="640080" y="1053211"/>
+            <a:off x="640080" y="1472311"/>
             <a:ext cx="10909300" cy="2590800"/>
           </a:xfrm>
           <a:prstGeom prst="roundRect">
@@ -18141,7 +18573,7 @@
         </p:nvSpPr>
         <p:spPr>
           <a:xfrm>
-            <a:off x="640080" y="1053211"/>
+            <a:off x="640080" y="1472311"/>
             <a:ext cx="76200" cy="2590800"/>
           </a:xfrm>
           <a:prstGeom prst="rect">
@@ -18212,7 +18644,7 @@
         </p:nvSpPr>
         <p:spPr>
           <a:xfrm>
-            <a:off x="640080" y="3796411"/>
+            <a:off x="640080" y="4215511"/>
             <a:ext cx="10909300" cy="1502664"/>
           </a:xfrm>
           <a:prstGeom prst="rect">
@@ -18545,7 +18977,7 @@
         </p:nvGraphicFramePr>
         <p:xfrm>
           <a:off x="640080" y="1053211"/>
-          <a:ext cx="10909300" cy="1778000"/>
+          <a:ext cx="10896600" cy="2202053"/>
         </p:xfrm>
         <a:graphic>
           <a:graphicData uri="http://schemas.openxmlformats.org/drawingml/2006/table">
@@ -19541,7 +19973,7 @@
         </p:nvGraphicFramePr>
         <p:xfrm>
           <a:off x="640080" y="1053211"/>
-          <a:ext cx="10909300" cy="1524000"/>
+          <a:ext cx="10909300" cy="2840990"/>
         </p:xfrm>
         <a:graphic>
           <a:graphicData uri="http://schemas.openxmlformats.org/drawingml/2006/table">
@@ -20899,7 +21331,7 @@
         </p:nvGraphicFramePr>
         <p:xfrm>
           <a:off x="640080" y="1053211"/>
-          <a:ext cx="10909300" cy="1016000"/>
+          <a:ext cx="10909300" cy="1973453"/>
         </p:xfrm>
         <a:graphic>
           <a:graphicData uri="http://schemas.openxmlformats.org/drawingml/2006/table">
@@ -21547,7 +21979,7 @@
         </p:nvSpPr>
         <p:spPr>
           <a:xfrm>
-            <a:off x="1005840" y="2377440"/>
+            <a:off x="975360" y="2148840"/>
             <a:ext cx="10241280" cy="769441"/>
           </a:xfrm>
           <a:prstGeom prst="rect">
@@ -21567,7 +21999,7 @@
               </a:lnSpc>
             </a:pPr>
             <a:r>
-              <a:rPr lang="pt-BR" sz="4400" b="1" i="0">
+              <a:rPr lang="pt-BR" sz="4400" b="1" i="0" dirty="0">
                 <a:solidFill>
                   <a:srgbClr val="FFFFFF"/>
                 </a:solidFill>
@@ -21575,7 +22007,7 @@
               </a:rPr>
               <a:t>QA/QC: garantir e controlar a qualidade</a:t>
             </a:r>
-            <a:endParaRPr sz="4400" b="1" i="0">
+            <a:endParaRPr sz="4400" b="1" i="0" dirty="0">
               <a:solidFill>
                 <a:srgbClr val="FFFFFF"/>
               </a:solidFill>
@@ -21869,7 +22301,7 @@
         </p:nvGraphicFramePr>
         <p:xfrm>
           <a:off x="640080" y="1053211"/>
-          <a:ext cx="10909300" cy="1524000"/>
+          <a:ext cx="10909300" cy="2364232"/>
         </p:xfrm>
         <a:graphic>
           <a:graphicData uri="http://schemas.openxmlformats.org/drawingml/2006/table">
@@ -22768,7 +23200,7 @@
         </p:nvGraphicFramePr>
         <p:xfrm>
           <a:off x="640080" y="1053211"/>
-          <a:ext cx="10909300" cy="2032000"/>
+          <a:ext cx="10909300" cy="4423664"/>
         </p:xfrm>
         <a:graphic>
           <a:graphicData uri="http://schemas.openxmlformats.org/drawingml/2006/table">
@@ -24565,7 +24997,7 @@
         </p:nvGraphicFramePr>
         <p:xfrm>
           <a:off x="640080" y="1053211"/>
-          <a:ext cx="10909300" cy="1778000"/>
+          <a:ext cx="10909300" cy="2678811"/>
         </p:xfrm>
         <a:graphic>
           <a:graphicData uri="http://schemas.openxmlformats.org/drawingml/2006/table">
@@ -26256,7 +26688,7 @@
         </p:nvGraphicFramePr>
         <p:xfrm>
           <a:off x="640080" y="1053211"/>
-          <a:ext cx="10909300" cy="1778000"/>
+          <a:ext cx="10909300" cy="2202053"/>
         </p:xfrm>
         <a:graphic>
           <a:graphicData uri="http://schemas.openxmlformats.org/drawingml/2006/table">
@@ -27662,7 +28094,7 @@
         </p:nvSpPr>
         <p:spPr>
           <a:xfrm>
-            <a:off x="1005840" y="2377440"/>
+            <a:off x="975360" y="2269490"/>
             <a:ext cx="10241280" cy="769441"/>
           </a:xfrm>
           <a:prstGeom prst="rect">
@@ -27682,7 +28114,7 @@
               </a:lnSpc>
             </a:pPr>
             <a:r>
-              <a:rPr lang="pt-BR" sz="4400" b="1" i="0">
+              <a:rPr lang="pt-BR" sz="4400" b="1" i="0" dirty="0">
                 <a:solidFill>
                   <a:srgbClr val="FFFFFF"/>
                 </a:solidFill>
@@ -27690,7 +28122,7 @@
               </a:rPr>
               <a:t>Por que os dados vêm antes da IA</a:t>
             </a:r>
-            <a:endParaRPr sz="4400" b="1" i="0">
+            <a:endParaRPr sz="4400" b="1" i="0" dirty="0">
               <a:solidFill>
                 <a:srgbClr val="FFFFFF"/>
               </a:solidFill>
@@ -28700,7 +29132,7 @@
         </p:nvGraphicFramePr>
         <p:xfrm>
           <a:off x="640080" y="1053211"/>
-          <a:ext cx="10909300" cy="1524000"/>
+          <a:ext cx="10909300" cy="3079369"/>
         </p:xfrm>
         <a:graphic>
           <a:graphicData uri="http://schemas.openxmlformats.org/drawingml/2006/table">
@@ -29665,7 +30097,7 @@
         </p:nvGraphicFramePr>
         <p:xfrm>
           <a:off x="640080" y="1053211"/>
-          <a:ext cx="10909300" cy="1778000"/>
+          <a:ext cx="10909300" cy="2678811"/>
         </p:xfrm>
         <a:graphic>
           <a:graphicData uri="http://schemas.openxmlformats.org/drawingml/2006/table">
@@ -30929,7 +31361,7 @@
         </p:nvGraphicFramePr>
         <p:xfrm>
           <a:off x="640080" y="2555875"/>
-          <a:ext cx="10909300" cy="1524000"/>
+          <a:ext cx="10909300" cy="1887474"/>
         </p:xfrm>
         <a:graphic>
           <a:graphicData uri="http://schemas.openxmlformats.org/drawingml/2006/table">
@@ -32030,14 +32462,14 @@
           <p:nvPr>
             <p:extLst>
               <p:ext uri="{D42A27DB-BD31-4B8C-83A1-F6EECF244321}">
-                <p14:modId xmlns:p14="http://schemas.microsoft.com/office/powerpoint/2010/main" val="3354808959"/>
+                <p14:modId xmlns:p14="http://schemas.microsoft.com/office/powerpoint/2010/main" val="2956430786"/>
               </p:ext>
             </p:extLst>
           </p:nvPr>
         </p:nvGraphicFramePr>
         <p:xfrm>
-          <a:off x="640080" y="1053211"/>
-          <a:ext cx="10909300" cy="1778000"/>
+          <a:off x="640080" y="1688211"/>
+          <a:ext cx="10896600" cy="2917190"/>
         </p:xfrm>
         <a:graphic>
           <a:graphicData uri="http://schemas.openxmlformats.org/drawingml/2006/table">
@@ -32086,7 +32518,7 @@
                         </a:spcAft>
                       </a:pPr>
                       <a:r>
-                        <a:rPr lang="en-US" sz="1700" b="1" i="0">
+                        <a:rPr lang="en-US" sz="1700" b="1" i="0" dirty="0">
                           <a:solidFill>
                             <a:srgbClr val="FFFFFF"/>
                           </a:solidFill>
@@ -32806,7 +33238,7 @@
                         </a:spcAft>
                       </a:pPr>
                       <a:r>
-                        <a:rPr lang="pt-BR" sz="1700" b="0" i="0">
+                        <a:rPr lang="pt-BR" sz="1700" b="0" i="0" dirty="0">
                           <a:solidFill>
                             <a:srgbClr val="2E3A2F"/>
                           </a:solidFill>
@@ -32814,7 +33246,7 @@
                         </a:rPr>
                         <a:t>tabela de ambientes com código único</a:t>
                       </a:r>
-                      <a:endParaRPr lang="en-US" sz="1700" b="0" i="0">
+                      <a:endParaRPr lang="en-US" sz="1700" b="0" i="0" dirty="0">
                         <a:solidFill>
                           <a:srgbClr val="2E3A2F"/>
                         </a:solidFill>
@@ -33439,7 +33871,7 @@
         </p:nvGraphicFramePr>
         <p:xfrm>
           <a:off x="640080" y="1053211"/>
-          <a:ext cx="10909300" cy="2032000"/>
+          <a:ext cx="10909300" cy="2755011"/>
         </p:xfrm>
         <a:graphic>
           <a:graphicData uri="http://schemas.openxmlformats.org/drawingml/2006/table">
@@ -34375,7 +34807,7 @@
         </p:nvSpPr>
         <p:spPr>
           <a:xfrm>
-            <a:off x="640080" y="1053210"/>
+            <a:off x="640080" y="1592960"/>
             <a:ext cx="10909300" cy="637032"/>
           </a:xfrm>
           <a:prstGeom prst="rect">
@@ -34462,7 +34894,7 @@
         </p:nvSpPr>
         <p:spPr>
           <a:xfrm>
-            <a:off x="640080" y="1842642"/>
+            <a:off x="640080" y="2382392"/>
             <a:ext cx="10909300" cy="807720"/>
           </a:xfrm>
           <a:prstGeom prst="roundRect">
@@ -34575,7 +35007,7 @@
         </p:nvSpPr>
         <p:spPr>
           <a:xfrm>
-            <a:off x="640080" y="1842642"/>
+            <a:off x="640080" y="2382392"/>
             <a:ext cx="76200" cy="807720"/>
           </a:xfrm>
           <a:prstGeom prst="rect">
@@ -34646,7 +35078,7 @@
         </p:nvSpPr>
         <p:spPr>
           <a:xfrm>
-            <a:off x="640080" y="2802762"/>
+            <a:off x="640080" y="3342512"/>
             <a:ext cx="10909300" cy="1350264"/>
           </a:xfrm>
           <a:prstGeom prst="rect">
@@ -35059,7 +35491,7 @@
         </p:nvGraphicFramePr>
         <p:xfrm>
           <a:off x="640080" y="2275459"/>
-          <a:ext cx="10909300" cy="1270000"/>
+          <a:ext cx="10909300" cy="1811274"/>
         </p:xfrm>
         <a:graphic>
           <a:graphicData uri="http://schemas.openxmlformats.org/drawingml/2006/table">
@@ -36360,7 +36792,7 @@
         </p:nvSpPr>
         <p:spPr>
           <a:xfrm>
-            <a:off x="640080" y="1053211"/>
+            <a:off x="640080" y="1548511"/>
             <a:ext cx="5308600" cy="2520696"/>
           </a:xfrm>
           <a:prstGeom prst="rect">
@@ -36557,7 +36989,7 @@
         </p:nvSpPr>
         <p:spPr>
           <a:xfrm>
-            <a:off x="6240780" y="1053211"/>
+            <a:off x="6240780" y="1548511"/>
             <a:ext cx="5308600" cy="2520696"/>
           </a:xfrm>
           <a:prstGeom prst="rect">
@@ -36786,7 +37218,7 @@
         </p:nvSpPr>
         <p:spPr>
           <a:xfrm>
-            <a:off x="1005840" y="2377440"/>
+            <a:off x="897890" y="2188190"/>
             <a:ext cx="10241280" cy="1446550"/>
           </a:xfrm>
           <a:prstGeom prst="rect">
@@ -36806,15 +37238,24 @@
               </a:lnSpc>
             </a:pPr>
             <a:r>
-              <a:rPr lang="pt-BR" sz="4400" b="1" i="0">
+              <a:rPr lang="pt-BR" sz="4400" b="1" i="0" dirty="0">
                 <a:solidFill>
                   <a:srgbClr val="FFFFFF"/>
                 </a:solidFill>
                 <a:latin typeface="DejaVu Serif"/>
               </a:rPr>
-              <a:t>A pasta de análise como projeto do Claude Code</a:t>
-            </a:r>
-            <a:endParaRPr sz="4400" b="1" i="0">
+              <a:t>A pasta de análise como projeto do Claude </a:t>
+            </a:r>
+            <a:r>
+              <a:rPr lang="pt-BR" sz="4400" b="1" i="0" dirty="0" err="1">
+                <a:solidFill>
+                  <a:srgbClr val="FFFFFF"/>
+                </a:solidFill>
+                <a:latin typeface="DejaVu Serif"/>
+              </a:rPr>
+              <a:t>Code</a:t>
+            </a:r>
+            <a:endParaRPr sz="4400" b="1" i="0" dirty="0">
               <a:solidFill>
                 <a:srgbClr val="FFFFFF"/>
               </a:solidFill>
@@ -38698,7 +39139,7 @@
         </p:nvGraphicFramePr>
         <p:xfrm>
           <a:off x="640080" y="1053211"/>
-          <a:ext cx="10909300" cy="1270000"/>
+          <a:ext cx="10922000" cy="1572895"/>
         </p:xfrm>
         <a:graphic>
           <a:graphicData uri="http://schemas.openxmlformats.org/drawingml/2006/table">
@@ -40792,7 +41233,7 @@
         </p:nvGraphicFramePr>
         <p:xfrm>
           <a:off x="640080" y="1053211"/>
-          <a:ext cx="10909300" cy="2032000"/>
+          <a:ext cx="10909300" cy="2516632"/>
         </p:xfrm>
         <a:graphic>
           <a:graphicData uri="http://schemas.openxmlformats.org/drawingml/2006/table">
@@ -42820,7 +43261,7 @@
         <p:spPr>
           <a:xfrm>
             <a:off x="640080" y="384048"/>
-            <a:ext cx="10972800" cy="588494"/>
+            <a:ext cx="12453620" cy="970587"/>
           </a:xfrm>
           <a:prstGeom prst="rect">
             <a:avLst/>
@@ -42839,7 +43280,7 @@
               </a:lnSpc>
             </a:pPr>
             <a:r>
-              <a:rPr lang="pt-BR" sz="3200" b="1" i="0">
+              <a:rPr lang="pt-BR" sz="2800" b="1" i="0" dirty="0">
                 <a:solidFill>
                   <a:srgbClr val="4A7C59"/>
                 </a:solidFill>
@@ -42847,7 +43288,7 @@
               </a:rPr>
               <a:t>1.2  O ciclo de vida do dado em um programa de melhoramento</a:t>
             </a:r>
-            <a:endParaRPr sz="3200" b="1" i="0">
+            <a:endParaRPr sz="2800" b="1" i="0" dirty="0">
               <a:solidFill>
                 <a:srgbClr val="4A7C59"/>
               </a:solidFill>
@@ -42915,7 +43356,7 @@
         </p:nvSpPr>
         <p:spPr>
           <a:xfrm>
-            <a:off x="381000" y="1053211"/>
+            <a:off x="381000" y="1700911"/>
             <a:ext cx="1502228" cy="1104075"/>
           </a:xfrm>
           <a:prstGeom prst="roundRect">
@@ -43027,7 +43468,7 @@
         </p:nvSpPr>
         <p:spPr>
           <a:xfrm>
-            <a:off x="2035629" y="1053211"/>
+            <a:off x="2035629" y="1700911"/>
             <a:ext cx="1502228" cy="1104075"/>
           </a:xfrm>
           <a:prstGeom prst="roundRect">
@@ -43139,7 +43580,7 @@
         </p:nvSpPr>
         <p:spPr>
           <a:xfrm>
-            <a:off x="3690257" y="1053211"/>
+            <a:off x="3690257" y="1700911"/>
             <a:ext cx="1502229" cy="1104075"/>
           </a:xfrm>
           <a:prstGeom prst="roundRect">
@@ -43251,7 +43692,7 @@
         </p:nvSpPr>
         <p:spPr>
           <a:xfrm>
-            <a:off x="5344886" y="1053211"/>
+            <a:off x="5344886" y="1700911"/>
             <a:ext cx="1502229" cy="1104075"/>
           </a:xfrm>
           <a:prstGeom prst="roundRect">
@@ -43369,7 +43810,7 @@
         </p:nvSpPr>
         <p:spPr>
           <a:xfrm>
-            <a:off x="6999515" y="1053211"/>
+            <a:off x="6999515" y="1700911"/>
             <a:ext cx="1502228" cy="1104075"/>
           </a:xfrm>
           <a:prstGeom prst="roundRect">
@@ -43481,7 +43922,7 @@
         </p:nvSpPr>
         <p:spPr>
           <a:xfrm>
-            <a:off x="8654143" y="1053212"/>
+            <a:off x="8654143" y="1700912"/>
             <a:ext cx="1502229" cy="1104075"/>
           </a:xfrm>
           <a:prstGeom prst="roundRect">
@@ -43593,7 +44034,7 @@
         </p:nvSpPr>
         <p:spPr>
           <a:xfrm>
-            <a:off x="10308772" y="1053211"/>
+            <a:off x="10308772" y="1700911"/>
             <a:ext cx="1502228" cy="1104075"/>
           </a:xfrm>
           <a:prstGeom prst="roundRect">
@@ -43705,7 +44146,7 @@
         </p:nvSpPr>
         <p:spPr>
           <a:xfrm>
-            <a:off x="1921329" y="1516348"/>
+            <a:off x="1921329" y="2195798"/>
             <a:ext cx="76200" cy="177801"/>
           </a:xfrm>
           <a:prstGeom prst="rightArrow">
@@ -43776,7 +44217,7 @@
         </p:nvSpPr>
         <p:spPr>
           <a:xfrm>
-            <a:off x="3575957" y="1516348"/>
+            <a:off x="3575957" y="2195798"/>
             <a:ext cx="76200" cy="177801"/>
           </a:xfrm>
           <a:prstGeom prst="rightArrow">
@@ -43847,7 +44288,7 @@
         </p:nvSpPr>
         <p:spPr>
           <a:xfrm>
-            <a:off x="5230586" y="1516348"/>
+            <a:off x="5230586" y="2195798"/>
             <a:ext cx="76200" cy="177801"/>
           </a:xfrm>
           <a:prstGeom prst="rightArrow">
@@ -43918,7 +44359,7 @@
         </p:nvSpPr>
         <p:spPr>
           <a:xfrm>
-            <a:off x="6885215" y="1516348"/>
+            <a:off x="6885215" y="2195798"/>
             <a:ext cx="76200" cy="177801"/>
           </a:xfrm>
           <a:prstGeom prst="rightArrow">
@@ -43989,7 +44430,7 @@
         </p:nvSpPr>
         <p:spPr>
           <a:xfrm>
-            <a:off x="8539843" y="1516348"/>
+            <a:off x="8539843" y="2195798"/>
             <a:ext cx="76200" cy="177801"/>
           </a:xfrm>
           <a:prstGeom prst="rightArrow">
@@ -44060,7 +44501,7 @@
         </p:nvSpPr>
         <p:spPr>
           <a:xfrm>
-            <a:off x="10194472" y="1516348"/>
+            <a:off x="10194472" y="2195798"/>
             <a:ext cx="76200" cy="177801"/>
           </a:xfrm>
           <a:prstGeom prst="rightArrow">
@@ -44131,7 +44572,7 @@
         </p:nvSpPr>
         <p:spPr>
           <a:xfrm>
-            <a:off x="640080" y="2360486"/>
+            <a:off x="640080" y="3039936"/>
             <a:ext cx="10909300" cy="2343912"/>
           </a:xfrm>
           <a:prstGeom prst="rect">
@@ -45337,7 +45778,7 @@
         </p:nvSpPr>
         <p:spPr>
           <a:xfrm>
-            <a:off x="640080" y="1053211"/>
+            <a:off x="671830" y="1735836"/>
             <a:ext cx="10909300" cy="3386328"/>
           </a:xfrm>
           <a:prstGeom prst="rect">
@@ -45363,7 +45804,7 @@
               </a:spcAft>
             </a:pPr>
             <a:r>
-              <a:rPr lang="pt-BR" sz="2000">
+              <a:rPr lang="pt-BR" sz="2000" dirty="0">
                 <a:solidFill>
                   <a:srgbClr val="2E3A2F"/>
                 </a:solidFill>
@@ -45385,7 +45826,7 @@
               </a:spcAft>
             </a:pPr>
             <a:r>
-              <a:rPr lang="pt-BR" sz="2000">
+              <a:rPr lang="pt-BR" sz="2000" dirty="0">
                 <a:solidFill>
                   <a:srgbClr val="2E3A2F"/>
                 </a:solidFill>
@@ -45407,7 +45848,7 @@
               </a:spcAft>
             </a:pPr>
             <a:r>
-              <a:rPr lang="pt-BR" sz="2000">
+              <a:rPr lang="pt-BR" sz="2000" dirty="0">
                 <a:solidFill>
                   <a:srgbClr val="2E3A2F"/>
                 </a:solidFill>
@@ -45429,7 +45870,7 @@
               </a:spcAft>
             </a:pPr>
             <a:r>
-              <a:rPr lang="pt-BR" sz="2000">
+              <a:rPr lang="pt-BR" sz="2000" dirty="0">
                 <a:solidFill>
                   <a:srgbClr val="2E3A2F"/>
                 </a:solidFill>
@@ -45451,7 +45892,7 @@
               </a:spcAft>
             </a:pPr>
             <a:r>
-              <a:rPr lang="pt-BR" sz="2000">
+              <a:rPr lang="pt-BR" sz="2000" dirty="0">
                 <a:solidFill>
                   <a:srgbClr val="2E3A2F"/>
                 </a:solidFill>
@@ -45473,7 +45914,7 @@
               </a:spcAft>
             </a:pPr>
             <a:r>
-              <a:rPr lang="pt-BR" sz="2000">
+              <a:rPr lang="pt-BR" sz="2000" dirty="0">
                 <a:solidFill>
                   <a:srgbClr val="2E3A2F"/>
                 </a:solidFill>
@@ -45495,7 +45936,7 @@
               </a:spcAft>
             </a:pPr>
             <a:r>
-              <a:rPr lang="pt-BR" sz="2000">
+              <a:rPr lang="pt-BR" sz="2000" dirty="0">
                 <a:solidFill>
                   <a:srgbClr val="2E3A2F"/>
                 </a:solidFill>
@@ -45517,7 +45958,7 @@
               </a:spcAft>
             </a:pPr>
             <a:r>
-              <a:rPr lang="pt-BR" sz="2000">
+              <a:rPr lang="pt-BR" sz="2000" dirty="0">
                 <a:solidFill>
                   <a:srgbClr val="2E3A2F"/>
                 </a:solidFill>
@@ -45525,7 +45966,7 @@
               </a:rPr>
               <a:t>☐ Apagar os resultados e rodar os scripts recria tudo</a:t>
             </a:r>
-            <a:endParaRPr lang="en-US" sz="2000">
+            <a:endParaRPr lang="en-US" sz="2000" dirty="0">
               <a:solidFill>
                 <a:srgbClr val="2E3A2F"/>
               </a:solidFill>
@@ -46635,7 +47076,7 @@
         </p:nvSpPr>
         <p:spPr>
           <a:xfrm>
-            <a:off x="640080" y="1053211"/>
+            <a:off x="640080" y="1561211"/>
             <a:ext cx="10909300" cy="2343912"/>
           </a:xfrm>
           <a:prstGeom prst="rect">
@@ -46769,7 +47210,7 @@
         </p:nvSpPr>
         <p:spPr>
           <a:xfrm>
-            <a:off x="640080" y="3549523"/>
+            <a:off x="640080" y="4057523"/>
             <a:ext cx="10909300" cy="1095248"/>
           </a:xfrm>
           <a:prstGeom prst="roundRect">
@@ -46865,7 +47306,7 @@
         </p:nvSpPr>
         <p:spPr>
           <a:xfrm>
-            <a:off x="640080" y="3549523"/>
+            <a:off x="640080" y="4057523"/>
             <a:ext cx="63500" cy="1095248"/>
           </a:xfrm>
           <a:prstGeom prst="rect">
@@ -47014,7 +47455,7 @@
         <p:spPr>
           <a:xfrm>
             <a:off x="640080" y="384048"/>
-            <a:ext cx="10972800" cy="588494"/>
+            <a:ext cx="12053570" cy="588494"/>
           </a:xfrm>
           <a:prstGeom prst="rect">
             <a:avLst/>
@@ -47033,7 +47474,7 @@
               </a:lnSpc>
             </a:pPr>
             <a:r>
-              <a:rPr lang="pt-BR" sz="3200" b="1" i="0">
+              <a:rPr lang="pt-BR" sz="3200" b="1" i="0" dirty="0">
                 <a:solidFill>
                   <a:srgbClr val="4A7C59"/>
                 </a:solidFill>
@@ -47041,7 +47482,7 @@
               </a:rPr>
               <a:t>1.4  Consequência genética de um erro de dado</a:t>
             </a:r>
-            <a:endParaRPr sz="3200" b="1" i="0">
+            <a:endParaRPr sz="3200" b="1" i="0" dirty="0">
               <a:solidFill>
                 <a:srgbClr val="4A7C59"/>
               </a:solidFill>
@@ -47117,7 +47558,7 @@
         </p:nvGraphicFramePr>
         <p:xfrm>
           <a:off x="640080" y="1053211"/>
-          <a:ext cx="10909300" cy="1778000"/>
+          <a:ext cx="10909300" cy="3632327"/>
         </p:xfrm>
         <a:graphic>
           <a:graphicData uri="http://schemas.openxmlformats.org/drawingml/2006/table">
@@ -48698,7 +49139,7 @@
         </p:nvSpPr>
         <p:spPr>
           <a:xfrm>
-            <a:off x="1005840" y="2377440"/>
+            <a:off x="944880" y="2137898"/>
             <a:ext cx="10241280" cy="1446550"/>
           </a:xfrm>
           <a:prstGeom prst="rect">
@@ -48718,7 +49159,7 @@
               </a:lnSpc>
             </a:pPr>
             <a:r>
-              <a:rPr lang="pt-BR" sz="4400" b="1" i="0">
+              <a:rPr lang="pt-BR" sz="4400" b="1" i="0" dirty="0">
                 <a:solidFill>
                   <a:srgbClr val="FFFFFF"/>
                 </a:solidFill>
@@ -48726,7 +49167,7 @@
               </a:rPr>
               <a:t>Bancos de dados relacionais e a linguagem SQL</a:t>
             </a:r>
-            <a:endParaRPr sz="4400" b="1" i="0">
+            <a:endParaRPr sz="4400" b="1" i="0" dirty="0">
               <a:solidFill>
                 <a:srgbClr val="FFFFFF"/>
               </a:solidFill>

</xml_diff>